<commit_message>
docs(slides): apply some edits to the presentation
</commit_message>
<xml_diff>
--- a/docs/slides/Midterm_Presentation_Bobas_Vasylchenko_Hombosh.pptx
+++ b/docs/slides/Midterm_Presentation_Bobas_Vasylchenko_Hombosh.pptx
@@ -5969,7 +5969,7 @@
         <p:spPr>
           <a:xfrm>
             <a:off x="548640" y="3520440"/>
-            <a:ext cx="3514344" cy="2377440"/>
+            <a:ext cx="3514344" cy="2606040"/>
           </a:xfrm>
           <a:prstGeom prst="roundRect">
             <a:avLst>
@@ -6106,7 +6106,7 @@
                 </a:solidFill>
                 <a:latin typeface="Calibri"/>
               </a:rPr>
-              <a:t>кожен агент — вектор: положення, розмір, курс, швидкість, клас</a:t>
+              <a:t>кожен обʼєкт — вектор: положення, розмір, курс, швидкість, клас</a:t>
             </a:r>
           </a:p>
           <a:p>
@@ -6145,7 +6145,7 @@
         <p:spPr>
           <a:xfrm>
             <a:off x="4337304" y="3520440"/>
-            <a:ext cx="3514344" cy="2377440"/>
+            <a:ext cx="3514344" cy="2606040"/>
           </a:xfrm>
           <a:prstGeom prst="roundRect">
             <a:avLst>
@@ -6307,7 +6307,7 @@
                 </a:solidFill>
                 <a:latin typeface="Calibri"/>
               </a:rPr>
-              <a:t>поширений підхід до злиття сенсорів; вміщається в GPU Colab</a:t>
+              <a:t>популярна архітектура для об'єднання камер і LiDAR; достатньо легка для безкоштовного GPU в Colab</a:t>
             </a:r>
           </a:p>
         </p:txBody>
@@ -6321,7 +6321,7 @@
         <p:spPr>
           <a:xfrm>
             <a:off x="8125968" y="3520440"/>
-            <a:ext cx="3514344" cy="2377440"/>
+            <a:ext cx="3514344" cy="2606040"/>
           </a:xfrm>
           <a:prstGeom prst="roundRect">
             <a:avLst>
@@ -7067,7 +7067,7 @@
                           </a:solidFill>
                           <a:latin typeface="Calibri"/>
                         </a:rPr>
-                        <a:t>перетин авто з іншими агентами</a:t>
+                        <a:t>перетин авто з іншими обʼєктами</a:t>
                       </a:r>
                     </a:p>
                   </a:txBody>
@@ -7571,35 +7571,6 @@
                 <a:latin typeface="Calibri"/>
               </a:rPr>
               <a:t>остання виміряна швидкість</a:t>
-            </a:r>
-          </a:p>
-          <a:p>
-            <a:pPr algn="l" marL="201168" indent="-201168">
-              <a:spcAft>
-                <a:spcPts val="1200"/>
-              </a:spcAft>
-              <a:buClr>
-                <a:srgbClr val="38BDF8"/>
-              </a:buClr>
-              <a:buChar char="•"/>
-            </a:pPr>
-            <a:r>
-              <a:rPr sz="1600" b="1" i="0">
-                <a:solidFill>
-                  <a:srgbClr val="F1F5F9"/>
-                </a:solidFill>
-                <a:latin typeface="Calibri"/>
-              </a:rPr>
-              <a:t>Ego-status MLP (план): </a:t>
-            </a:r>
-            <a:r>
-              <a:rPr sz="1600" b="0" i="0">
-                <a:solidFill>
-                  <a:srgbClr val="F1F5F9"/>
-                </a:solidFill>
-                <a:latin typeface="Calibri"/>
-              </a:rPr>
-              <a:t>чи не вирішує все сама швидкість его</a:t>
             </a:r>
           </a:p>
         </p:txBody>
@@ -9092,7 +9063,7 @@
                 </a:solidFill>
                 <a:latin typeface="Calibri"/>
               </a:rPr>
-              <a:t>Тестова сцена: жовте — водій, зелене — прогноз (у PPTX — анімація)</a:t>
+              <a:t>Тестова сцена: жовте — водій, зелене — прогноз</a:t>
             </a:r>
           </a:p>
         </p:txBody>
@@ -9212,7 +9183,7 @@
                 </a:solidFill>
                 <a:latin typeface="Calibri"/>
               </a:rPr>
-              <a:t>Object-centric: сцена без втрат, CV — сильний бейзлайн</a:t>
+              <a:t>Object-centric: Constant Velocity — сильний бейзлайн</a:t>
             </a:r>
           </a:p>
         </p:txBody>
@@ -9251,7 +9222,7 @@
                 </a:solidFill>
                 <a:latin typeface="Calibri"/>
               </a:rPr>
-              <a:t>Усі 10 сцен mini, 16 295 вікон агентів, похибка в метрах (менше — краще)</a:t>
+              <a:t>Усі 10 сцен mini, 16 295 прогнозів (обʼєкт × момент часу), похибка в метрах (чим менше — тим краще)</a:t>
             </a:r>
           </a:p>
         </p:txBody>
@@ -9342,8 +9313,8 @@
         </p:nvSpPr>
         <p:spPr>
           <a:xfrm>
-            <a:off x="548640" y="2011680"/>
-            <a:ext cx="5943600" cy="914400"/>
+            <a:off x="548640" y="1783080"/>
+            <a:ext cx="5943600" cy="868680"/>
           </a:xfrm>
           <a:prstGeom prst="roundRect">
             <a:avLst>
@@ -9390,7 +9361,7 @@
         </p:nvSpPr>
         <p:spPr>
           <a:xfrm>
-            <a:off x="777240" y="2148840"/>
+            <a:off x="777240" y="1901952"/>
             <a:ext cx="5486400" cy="914400"/>
           </a:xfrm>
           <a:prstGeom prst="rect">
@@ -9425,7 +9396,7 @@
                 </a:solidFill>
                 <a:latin typeface="Calibri"/>
               </a:rPr>
-              <a:t>[кадри, агенти, 11 ознак], напр. [39, 227, 11]</a:t>
+              <a:t>[кадри, обʼєкти, 11 ознак], напр. [39, 227, 11]</a:t>
             </a:r>
           </a:p>
           <a:p>
@@ -9455,16 +9426,64 @@
           </a:p>
         </p:txBody>
       </p:sp>
+      <p:sp>
+        <p:nvSpPr>
+          <p:cNvPr id="9" name="TextBox 8"/>
+          <p:cNvSpPr txBox="1"/>
+          <p:nvPr/>
+        </p:nvSpPr>
+        <p:spPr>
+          <a:xfrm>
+            <a:off x="548640" y="2761488"/>
+            <a:ext cx="5943600" cy="548640"/>
+          </a:xfrm>
+          <a:prstGeom prst="rect">
+            <a:avLst/>
+          </a:prstGeom>
+          <a:noFill/>
+        </p:spPr>
+        <p:txBody>
+          <a:bodyPr wrap="square" anchor="t" lIns="0" rIns="0" tIns="0" bIns="0">
+            <a:spAutoFit/>
+          </a:bodyPr>
+          <a:lstStyle/>
+          <a:p>
+            <a:pPr algn="l">
+              <a:spcAft>
+                <a:spcPts val="600"/>
+              </a:spcAft>
+            </a:pPr>
+            <a:r>
+              <a:rPr sz="1400" b="1" i="0">
+                <a:solidFill>
+                  <a:srgbClr val="F1F5F9"/>
+                </a:solidFill>
+                <a:latin typeface="Calibri"/>
+              </a:rPr>
+              <a:t>Бейзлайни в object-centric представленні </a:t>
+            </a:r>
+            <a:r>
+              <a:rPr sz="1400" b="0" i="0">
+                <a:solidFill>
+                  <a:srgbClr val="94A3B8"/>
+                </a:solidFill>
+                <a:latin typeface="Calibri"/>
+              </a:rPr>
+              <a:t>(навчена модель — наш плановий наступний етап)</a:t>
+            </a:r>
+          </a:p>
+        </p:txBody>
+      </p:sp>
       <p:graphicFrame>
         <p:nvGraphicFramePr>
-          <p:cNvPr id="9" name="Table 8"/>
+          <p:cNvPr id="10" name="Table 9"/>
           <p:cNvGraphicFramePr>
             <a:graphicFrameLocks noGrp="1"/>
           </p:cNvGraphicFramePr>
           <p:nvPr/>
         </p:nvGraphicFramePr>
         <p:xfrm>
-          <a:off x="548640" y="3200400"/>
+          <a:off x="548640" y="3364992"/>
           <a:ext cx="5943600" cy="1645920"/>
         </p:xfrm>
         <a:graphic>
@@ -10137,13 +10156,13 @@
       </p:graphicFrame>
       <p:sp>
         <p:nvSpPr>
-          <p:cNvPr id="10" name="TextBox 9"/>
+          <p:cNvPr id="11" name="TextBox 10"/>
           <p:cNvSpPr txBox="1"/>
           <p:nvPr/>
         </p:nvSpPr>
         <p:spPr>
           <a:xfrm>
-            <a:off x="548640" y="5074920"/>
+            <a:off x="548640" y="5166360"/>
             <a:ext cx="5943600" cy="822960"/>
           </a:xfrm>
           <a:prstGeom prst="rect">
@@ -10178,14 +10197,14 @@
                 </a:solidFill>
                 <a:latin typeface="Calibri"/>
               </a:rPr>
-              <a:t>CV у 4× точніша за persistence; помиляється на поворотах і гальмуванні</a:t>
+              <a:t>Constant velocity: у середньому 0.98 м похибки через 3 с, у 4 рази точніше за persistence; помиляється на поворотах і гальмуванні. Це планка для нашої object-centric моделі.</a:t>
             </a:r>
           </a:p>
         </p:txBody>
       </p:sp>
       <p:pic>
         <p:nvPicPr>
-          <p:cNvPr id="11" name="Picture 10" descr="progress_object_forecasts.png"/>
+          <p:cNvPr id="12" name="Picture 11" descr="progress_object_forecasts.png"/>
           <p:cNvPicPr>
             <a:picLocks noChangeAspect="1"/>
           </p:cNvPicPr>
@@ -10209,7 +10228,7 @@
       </p:pic>
       <p:sp>
         <p:nvSpPr>
-          <p:cNvPr id="12" name="TextBox 11"/>
+          <p:cNvPr id="13" name="TextBox 12"/>
           <p:cNvSpPr txBox="1"/>
           <p:nvPr/>
         </p:nvSpPr>
@@ -11287,7 +11306,7 @@
                 </a:solidFill>
                 <a:latin typeface="Calibri"/>
               </a:rPr>
-              <a:t>Репозиторій і CI, конфіг-схема, метрики L2 / collision / Chamfer / FID з тестами, persistence-бейзлайн</a:t>
+              <a:t>Репозиторій і CI, конфіг-схема, метрики L2 / collision / Chamfer / FID з тестами, persistence-бейзлайн, візуалізації (камера, BEV, GIF)</a:t>
             </a:r>
           </a:p>
         </p:txBody>
@@ -11390,7 +11409,7 @@
                 </a:solidFill>
                 <a:latin typeface="Calibri"/>
               </a:rPr>
-              <a:t>nuScenes-лоадер, BEVFusion-енкодер і EgoPlanner, візуалізації (камера, BEV, GIF), слайди мідтерму</a:t>
+              <a:t>nuScenes-лоадер, BEVFusion-енкодер і EgoPlanner, слайди презентації</a:t>
             </a:r>
           </a:p>
         </p:txBody>
@@ -11493,7 +11512,7 @@
                 </a:solidFill>
                 <a:latin typeface="Calibri"/>
               </a:rPr>
-              <a:t>Object-centric представлення, ADE/FDE, ноутбук; аудит і виправлення методології BEV, навчання планера</a:t>
+              <a:t>Object-centric представлення, ADE/FDE, огляд і виправлення методології BEV-енкодера</a:t>
             </a:r>
           </a:p>
         </p:txBody>
@@ -11744,7 +11763,7 @@
         <p:spPr>
           <a:xfrm>
             <a:off x="548640" y="2011680"/>
-            <a:ext cx="2601468" cy="2011680"/>
+            <a:ext cx="2601468" cy="2194560"/>
           </a:xfrm>
           <a:prstGeom prst="roundRect">
             <a:avLst>
@@ -11882,7 +11901,7 @@
               </a:spcAft>
             </a:pPr>
             <a:r>
-              <a:rPr sz="1500" b="0" i="0">
+              <a:rPr sz="1400" b="0" i="0">
                 <a:solidFill>
                   <a:srgbClr val="F1F5F9"/>
                 </a:solidFill>
@@ -11902,7 +11921,7 @@
         <p:spPr>
           <a:xfrm>
             <a:off x="3378708" y="2011680"/>
-            <a:ext cx="2601468" cy="2011680"/>
+            <a:ext cx="2601468" cy="2194560"/>
           </a:xfrm>
           <a:prstGeom prst="roundRect">
             <a:avLst>
@@ -12040,13 +12059,13 @@
               </a:spcAft>
             </a:pPr>
             <a:r>
-              <a:rPr sz="1500" b="0" i="0">
+              <a:rPr sz="1400" b="0" i="0">
                 <a:solidFill>
                   <a:srgbClr val="F1F5F9"/>
                 </a:solidFill>
                 <a:latin typeface="Calibri"/>
               </a:rPr>
-              <a:t>нейромережа по треках агентів; спільна BEV-карта зайнятості</a:t>
+              <a:t>нейромережа прогнозує рух кожного агента за його минулими положеннями</a:t>
             </a:r>
           </a:p>
         </p:txBody>
@@ -12060,7 +12079,7 @@
         <p:spPr>
           <a:xfrm>
             <a:off x="6208776" y="2011680"/>
-            <a:ext cx="2601468" cy="2011680"/>
+            <a:ext cx="2601468" cy="2194560"/>
           </a:xfrm>
           <a:prstGeom prst="roundRect">
             <a:avLst>
@@ -12198,13 +12217,13 @@
               </a:spcAft>
             </a:pPr>
             <a:r>
-              <a:rPr sz="1500" b="0" i="0">
+              <a:rPr sz="1400" b="0" i="0">
                 <a:solidFill>
                   <a:srgbClr val="F1F5F9"/>
                 </a:solidFill>
                 <a:latin typeface="Calibri"/>
               </a:rPr>
-              <a:t>автоенкодер + прогноз у латентному просторі; до 150 сцен trainval</a:t>
+              <a:t>автоенкодер + прогноз у латентному просторі; прогнози всіх трьох підходів зводимо до однієї карти зверху</a:t>
             </a:r>
           </a:p>
         </p:txBody>
@@ -12218,7 +12237,7 @@
         <p:spPr>
           <a:xfrm>
             <a:off x="9038844" y="2011680"/>
-            <a:ext cx="2601468" cy="2011680"/>
+            <a:ext cx="2601468" cy="2194560"/>
           </a:xfrm>
           <a:prstGeom prst="roundRect">
             <a:avLst>
@@ -12356,7 +12375,7 @@
               </a:spcAft>
             </a:pPr>
             <a:r>
-              <a:rPr sz="1500" b="0" i="0">
+              <a:rPr sz="1400" b="0" i="0">
                 <a:solidFill>
                   <a:srgbClr val="F1F5F9"/>
                 </a:solidFill>
@@ -12375,8 +12394,8 @@
         </p:nvSpPr>
         <p:spPr>
           <a:xfrm>
-            <a:off x="548640" y="4206240"/>
-            <a:ext cx="3544824" cy="1920240"/>
+            <a:off x="548640" y="4343400"/>
+            <a:ext cx="3520440" cy="1828800"/>
           </a:xfrm>
           <a:prstGeom prst="roundRect">
             <a:avLst>
@@ -12423,8 +12442,8 @@
         </p:nvSpPr>
         <p:spPr>
           <a:xfrm>
-            <a:off x="731520" y="4343400"/>
-            <a:ext cx="3179064" cy="365760"/>
+            <a:off x="731520" y="4453128"/>
+            <a:ext cx="3154680" cy="365760"/>
           </a:xfrm>
           <a:prstGeom prst="rect">
             <a:avLst/>
@@ -12462,8 +12481,8 @@
         </p:nvSpPr>
         <p:spPr>
           <a:xfrm>
-            <a:off x="731520" y="4754880"/>
-            <a:ext cx="3179064" cy="1325880"/>
+            <a:off x="731520" y="4846320"/>
+            <a:ext cx="3154680" cy="1280160"/>
           </a:xfrm>
           <a:prstGeom prst="rect">
             <a:avLst/>
@@ -12478,7 +12497,7 @@
           <a:p>
             <a:pPr algn="l" marL="201168" indent="-201168">
               <a:spcAft>
-                <a:spcPts val="400"/>
+                <a:spcPts val="300"/>
               </a:spcAft>
               <a:buClr>
                 <a:srgbClr val="38BDF8"/>
@@ -12486,7 +12505,7 @@
               <a:buChar char="•"/>
             </a:pPr>
             <a:r>
-              <a:rPr sz="1500" b="0" i="0">
+              <a:rPr sz="1400" b="0" i="0">
                 <a:solidFill>
                   <a:srgbClr val="F1F5F9"/>
                 </a:solidFill>
@@ -12498,7 +12517,7 @@
           <a:p>
             <a:pPr algn="l" marL="201168" indent="-201168">
               <a:spcAft>
-                <a:spcPts val="400"/>
+                <a:spcPts val="300"/>
               </a:spcAft>
               <a:buClr>
                 <a:srgbClr val="38BDF8"/>
@@ -12506,7 +12525,7 @@
               <a:buChar char="•"/>
             </a:pPr>
             <a:r>
-              <a:rPr sz="1500" b="0" i="0">
+              <a:rPr sz="1400" b="0" i="0">
                 <a:solidFill>
                   <a:srgbClr val="F1F5F9"/>
                 </a:solidFill>
@@ -12518,7 +12537,7 @@
           <a:p>
             <a:pPr algn="l" marL="201168" indent="-201168">
               <a:spcAft>
-                <a:spcPts val="400"/>
+                <a:spcPts val="300"/>
               </a:spcAft>
               <a:buClr>
                 <a:srgbClr val="38BDF8"/>
@@ -12526,13 +12545,13 @@
               <a:buChar char="•"/>
             </a:pPr>
             <a:r>
-              <a:rPr sz="1500" b="0" i="0">
+              <a:rPr sz="1400" b="0" i="0">
                 <a:solidFill>
                   <a:srgbClr val="F1F5F9"/>
                 </a:solidFill>
                 <a:latin typeface="Calibri"/>
               </a:rPr>
-              <a:t>3 seeds, порівняння з CV</a:t>
+              <a:t>3 запуски з різним seed (середнє ± розкид), порівняння з constant velocity</a:t>
             </a:r>
           </a:p>
         </p:txBody>
@@ -12545,8 +12564,8 @@
         </p:nvSpPr>
         <p:spPr>
           <a:xfrm>
-            <a:off x="4322064" y="4206240"/>
-            <a:ext cx="3544824" cy="1920240"/>
+            <a:off x="4297680" y="4343400"/>
+            <a:ext cx="4142232" cy="1828800"/>
           </a:xfrm>
           <a:prstGeom prst="roundRect">
             <a:avLst>
@@ -12593,8 +12612,8 @@
         </p:nvSpPr>
         <p:spPr>
           <a:xfrm>
-            <a:off x="4504944" y="4343400"/>
-            <a:ext cx="3179064" cy="365760"/>
+            <a:off x="4480560" y="4453128"/>
+            <a:ext cx="3776472" cy="365760"/>
           </a:xfrm>
           <a:prstGeom prst="rect">
             <a:avLst/>
@@ -12632,8 +12651,8 @@
         </p:nvSpPr>
         <p:spPr>
           <a:xfrm>
-            <a:off x="4504944" y="4754880"/>
-            <a:ext cx="3179064" cy="1325880"/>
+            <a:off x="4480560" y="4846320"/>
+            <a:ext cx="3776472" cy="1280160"/>
           </a:xfrm>
           <a:prstGeom prst="rect">
             <a:avLst/>
@@ -12648,7 +12667,7 @@
           <a:p>
             <a:pPr algn="l" marL="201168" indent="-201168">
               <a:spcAft>
-                <a:spcPts val="400"/>
+                <a:spcPts val="300"/>
               </a:spcAft>
               <a:buClr>
                 <a:srgbClr val="38BDF8"/>
@@ -12656,19 +12675,19 @@
               <a:buChar char="•"/>
             </a:pPr>
             <a:r>
-              <a:rPr sz="1500" b="0" i="0">
+              <a:rPr sz="1400" b="0" i="0">
                 <a:solidFill>
                   <a:srgbClr val="F1F5F9"/>
                 </a:solidFill>
                 <a:latin typeface="Calibri"/>
               </a:rPr>
-              <a:t>дифузія не вміщається в GPU → простіший прогноз у латентному просторі</a:t>
+              <a:t>дифузійна модель (як у BEVWorld) завелика для GPU Colab → проста нейромережа, що прогнозує стиснену карту напряму</a:t>
             </a:r>
           </a:p>
           <a:p>
             <a:pPr algn="l" marL="201168" indent="-201168">
               <a:spcAft>
-                <a:spcPts val="400"/>
+                <a:spcPts val="300"/>
               </a:spcAft>
               <a:buClr>
                 <a:srgbClr val="38BDF8"/>
@@ -12676,7 +12695,7 @@
               <a:buChar char="•"/>
             </a:pPr>
             <a:r>
-              <a:rPr sz="1500" b="0" i="0">
+              <a:rPr sz="1400" b="0" i="0">
                 <a:solidFill>
                   <a:srgbClr val="F1F5F9"/>
                 </a:solidFill>
@@ -12695,8 +12714,8 @@
         </p:nvSpPr>
         <p:spPr>
           <a:xfrm>
-            <a:off x="8095488" y="4206240"/>
-            <a:ext cx="3544824" cy="1920240"/>
+            <a:off x="8668512" y="4343400"/>
+            <a:ext cx="2971800" cy="1828800"/>
           </a:xfrm>
           <a:prstGeom prst="roundRect">
             <a:avLst>
@@ -12743,8 +12762,8 @@
         </p:nvSpPr>
         <p:spPr>
           <a:xfrm>
-            <a:off x="8278367" y="4343400"/>
-            <a:ext cx="3179064" cy="365760"/>
+            <a:off x="8851392" y="4453128"/>
+            <a:ext cx="2606040" cy="365760"/>
           </a:xfrm>
           <a:prstGeom prst="rect">
             <a:avLst/>
@@ -12782,8 +12801,8 @@
         </p:nvSpPr>
         <p:spPr>
           <a:xfrm>
-            <a:off x="8278367" y="4754880"/>
-            <a:ext cx="3179064" cy="1325880"/>
+            <a:off x="8851392" y="4846320"/>
+            <a:ext cx="2606040" cy="1280160"/>
           </a:xfrm>
           <a:prstGeom prst="rect">
             <a:avLst/>
@@ -12798,7 +12817,7 @@
           <a:p>
             <a:pPr algn="l" marL="201168" indent="-201168">
               <a:spcAft>
-                <a:spcPts val="400"/>
+                <a:spcPts val="300"/>
               </a:spcAft>
               <a:buClr>
                 <a:srgbClr val="38BDF8"/>
@@ -12806,7 +12825,7 @@
               <a:buChar char="•"/>
             </a:pPr>
             <a:r>
-              <a:rPr sz="1500" b="0" i="0">
+              <a:rPr sz="1400" b="0" i="0">
                 <a:solidFill>
                   <a:srgbClr val="F1F5F9"/>
                 </a:solidFill>
@@ -12818,7 +12837,7 @@
           <a:p>
             <a:pPr algn="l" marL="201168" indent="-201168">
               <a:spcAft>
-                <a:spcPts val="400"/>
+                <a:spcPts val="300"/>
               </a:spcAft>
               <a:buClr>
                 <a:srgbClr val="38BDF8"/>
@@ -12826,7 +12845,7 @@
               <a:buChar char="•"/>
             </a:pPr>
             <a:r>
-              <a:rPr sz="1500" b="0" i="0">
+              <a:rPr sz="1400" b="0" i="0">
                 <a:solidFill>
                   <a:srgbClr val="F1F5F9"/>
                 </a:solidFill>

</xml_diff>